<commit_message>
chat : page Assistant branchée sur l'IA locale + historique des conversations
Malentendu corrigé : le chat devait être conservé, seulement sans le mock.
Backend : table messages_chat, GET/POST /chat (contexte : dernières constantes,
alerte en cours, 6 derniers échanges de CE colon), mêmes garde-fous que les
cartes (tutoiement, pas de diagnostic, filtre dose/médicament, pas de
minimisation), réponse de secours fixe si l'IA échoue ; le message ne
modifie jamais état, protocole, alerte ni stock. Front : composants du chat
restaurés (MessageBubble, ChatInput, TypingIndicator, Foxy) et page
/assistant qui charge et envoie via l'API ; la page Historique s'ouvre sur
l'onglet Conversations (relecture par jour), Recommandations en second.
Tests : chat IA, isolation, secours, validation, limite. Docs et livrables
mis à jour ; le chat est un ajout au-delà du CDC §2.
</commit_message>
<xml_diff>
--- a/docs/livrables/Workshop2026-B3-Pres.pptx
+++ b/docs/livrables/Workshop2026-B3-Pres.pptx
@@ -4021,7 +4021,7 @@
               <a:defRPr sz="2200"/>
             </a:pPr>
             <a:r>
-              <a:t>• Une IA locale décide de la conduite à tenir</a:t>
+              <a:t>• Une IA locale décide de la conduite à tenir et discute avec le colon</a:t>
             </a:r>
           </a:p>
           <a:p>
@@ -4880,17 +4880,6 @@
             <a:spAutoFit/>
           </a:bodyPr>
           <a:lstStyle/>
-          <a:p>
-            <a:pPr>
-              <a:spcAft>
-                <a:spcPts val="1000"/>
-              </a:spcAft>
-              <a:defRPr sz="2200"/>
-            </a:pPr>
-            <a:r>
-              <a:t>• Chat libre avec l'assistant</a:t>
-            </a:r>
-          </a:p>
           <a:p>
             <a:pPr>
               <a:spcAft>

</xml_diff>